<commit_message>
feat: implement AppStore module with 30+ new specialized manufacturing templates and supporting utility scripts
</commit_message>
<xml_diff>
--- a/mavi_mes_presentation_v2.pptx
+++ b/mavi_mes_presentation_v2.pptx
@@ -19,8 +19,9 @@
     <p:sldId id="264" r:id="rId13"/>
     <p:sldId id="265" r:id="rId14"/>
     <p:sldId id="266" r:id="rId15"/>
-    <p:sldId id="267" r:id="rId16"/>
-    <p:sldId id="268" r:id="rId17"/>
+    <p:sldId id="272" r:id="rId16"/>
+    <p:sldId id="267" r:id="rId17"/>
+    <p:sldId id="268" r:id="rId18"/>
   </p:sldIdLst>
   <p:sldSz cx="12188825" cy="6858000"/>
   <p:notesSz cx="6858000" cy="9144000"/>
@@ -3621,6 +3622,7 @@
               </a:defRPr>
             </a:pPr>
             <a:r>
+              <a:rPr dirty="0"/>
               <a:t>LANGKAH 01</a:t>
             </a:r>
           </a:p>
@@ -3637,6 +3639,7 @@
               </a:defRPr>
             </a:pPr>
             <a:r>
+              <a:rPr dirty="0"/>
               <a:t>INVENTORY</a:t>
             </a:r>
           </a:p>
@@ -3656,14 +3659,21 @@
               </a:defRPr>
             </a:pPr>
             <a:r>
+              <a:rPr dirty="0"/>
               <a:t>App Store Templates:</a:t>
             </a:r>
-            <a:br/>
-            <a:r>
+            <a:br>
+              <a:rPr dirty="0"/>
+            </a:br>
+            <a:r>
+              <a:rPr dirty="0"/>
               <a:t>• Material Warehouse</a:t>
             </a:r>
-            <a:br/>
-            <a:r>
+            <a:br>
+              <a:rPr dirty="0"/>
+            </a:br>
+            <a:r>
+              <a:rPr dirty="0"/>
               <a:t>• Inventory App Suite</a:t>
             </a:r>
           </a:p>
@@ -3683,11 +3693,55 @@
               </a:defRPr>
             </a:pPr>
             <a:r>
-              <a:t>Fungsi:</a:t>
-            </a:r>
-            <a:br/>
-            <a:r>
-              <a:t>Membangun tabel fondasi 'Inventory_Items' &amp; 'Material_Definitions'.</a:t>
+              <a:rPr dirty="0" err="1"/>
+              <a:t>Fungsi</a:t>
+            </a:r>
+            <a:r>
+              <a:rPr dirty="0"/>
+              <a:t>:</a:t>
+            </a:r>
+            <a:br>
+              <a:rPr dirty="0"/>
+            </a:br>
+            <a:r>
+              <a:rPr dirty="0" err="1"/>
+              <a:t>Membangun</a:t>
+            </a:r>
+            <a:r>
+              <a:rPr dirty="0"/>
+              <a:t> </a:t>
+            </a:r>
+            <a:r>
+              <a:rPr dirty="0" err="1"/>
+              <a:t>tabel</a:t>
+            </a:r>
+            <a:r>
+              <a:rPr dirty="0"/>
+              <a:t> </a:t>
+            </a:r>
+            <a:r>
+              <a:rPr dirty="0" err="1"/>
+              <a:t>fondasi</a:t>
+            </a:r>
+            <a:r>
+              <a:rPr dirty="0"/>
+              <a:t> '</a:t>
+            </a:r>
+            <a:r>
+              <a:rPr dirty="0" err="1"/>
+              <a:t>Inventory_Items</a:t>
+            </a:r>
+            <a:r>
+              <a:rPr dirty="0"/>
+              <a:t>' &amp; '</a:t>
+            </a:r>
+            <a:r>
+              <a:rPr dirty="0" err="1"/>
+              <a:t>Material_Definitions</a:t>
+            </a:r>
+            <a:r>
+              <a:rPr dirty="0"/>
+              <a:t>'.</a:t>
             </a:r>
           </a:p>
           <a:p>
@@ -3703,11 +3757,47 @@
               </a:defRPr>
             </a:pPr>
             <a:r>
-              <a:t>💡 Langkah Verifikasi:</a:t>
-            </a:r>
-            <a:br/>
-            <a:r>
-              <a:t>Buka Material Warehouse App. Pastikan dummy unit 'DEMO-CYL-A1' muncul di Rak BIN-12.</a:t>
+              <a:rPr dirty="0"/>
+              <a:t>💡 Langkah </a:t>
+            </a:r>
+            <a:r>
+              <a:rPr dirty="0" err="1"/>
+              <a:t>Verifikasi</a:t>
+            </a:r>
+            <a:r>
+              <a:rPr dirty="0"/>
+              <a:t>:</a:t>
+            </a:r>
+            <a:br>
+              <a:rPr dirty="0"/>
+            </a:br>
+            <a:r>
+              <a:rPr dirty="0"/>
+              <a:t>Buka Material Warehouse App. </a:t>
+            </a:r>
+            <a:r>
+              <a:rPr dirty="0" err="1"/>
+              <a:t>Pastikan</a:t>
+            </a:r>
+            <a:r>
+              <a:rPr dirty="0"/>
+              <a:t> dummy unit 'DEMO-CYL-A1' </a:t>
+            </a:r>
+            <a:r>
+              <a:rPr dirty="0" err="1"/>
+              <a:t>muncul</a:t>
+            </a:r>
+            <a:r>
+              <a:rPr dirty="0"/>
+              <a:t> di </a:t>
+            </a:r>
+            <a:r>
+              <a:rPr dirty="0" err="1"/>
+              <a:t>Rak</a:t>
+            </a:r>
+            <a:r>
+              <a:rPr dirty="0"/>
+              <a:t> BIN-12.</a:t>
             </a:r>
           </a:p>
         </p:txBody>
@@ -5918,6 +6008,36 @@
 <file path=ppt/slides/slide15.xml><?xml version="1.0" encoding="utf-8"?>
 <p:sld xmlns:a="http://schemas.openxmlformats.org/drawingml/2006/main" xmlns:r="http://schemas.openxmlformats.org/officeDocument/2006/relationships" xmlns:p="http://schemas.openxmlformats.org/presentationml/2006/main">
   <p:cSld>
+    <p:spTree>
+      <p:nvGrpSpPr>
+        <p:cNvPr id="1" name=""/>
+        <p:cNvGrpSpPr/>
+        <p:nvPr/>
+      </p:nvGrpSpPr>
+      <p:grpSpPr>
+        <a:xfrm>
+          <a:off x="0" y="0"/>
+          <a:ext cx="0" cy="0"/>
+          <a:chOff x="0" y="0"/>
+          <a:chExt cx="0" cy="0"/>
+        </a:xfrm>
+      </p:grpSpPr>
+    </p:spTree>
+    <p:extLst>
+      <p:ext uri="{BB962C8B-B14F-4D97-AF65-F5344CB8AC3E}">
+        <p14:creationId xmlns:p14="http://schemas.microsoft.com/office/powerpoint/2010/main" val="3175545449"/>
+      </p:ext>
+    </p:extLst>
+  </p:cSld>
+  <p:clrMapOvr>
+    <a:masterClrMapping/>
+  </p:clrMapOvr>
+</p:sld>
+</file>
+
+<file path=ppt/slides/slide16.xml><?xml version="1.0" encoding="utf-8"?>
+<p:sld xmlns:a="http://schemas.openxmlformats.org/drawingml/2006/main" xmlns:r="http://schemas.openxmlformats.org/officeDocument/2006/relationships" xmlns:p="http://schemas.openxmlformats.org/presentationml/2006/main">
+  <p:cSld>
     <p:bg>
       <p:bgPr>
         <a:solidFill>
@@ -6212,7 +6332,7 @@
 </p:sld>
 </file>
 
-<file path=ppt/slides/slide16.xml><?xml version="1.0" encoding="utf-8"?>
+<file path=ppt/slides/slide17.xml><?xml version="1.0" encoding="utf-8"?>
 <p:sld xmlns:a="http://schemas.openxmlformats.org/drawingml/2006/main" xmlns:r="http://schemas.openxmlformats.org/officeDocument/2006/relationships" xmlns:p="http://schemas.openxmlformats.org/presentationml/2006/main">
   <p:cSld>
     <p:bg>
@@ -6420,8 +6540,8 @@
         </p:nvSpPr>
         <p:spPr>
           <a:xfrm>
-            <a:off x="6908800" y="1997839"/>
-            <a:ext cx="4978400" cy="2862322"/>
+            <a:off x="6690437" y="518067"/>
+            <a:ext cx="4978400" cy="3693319"/>
           </a:xfrm>
           <a:prstGeom prst="rect">
             <a:avLst/>
@@ -6438,6 +6558,8 @@
               <a:rPr lang="nn-NO" b="1" dirty="0"/>
               <a:t>Dorong keputusan yang berdampak besar dengan data operasional real-time</a:t>
             </a:r>
+          </a:p>
+          <a:p>
             <a:endParaRPr lang="nn-NO" dirty="0"/>
           </a:p>
           <a:p>
@@ -6458,6 +6580,10 @@
             </a:r>
           </a:p>
           <a:p>
+            <a:pPr lvl="1"/>
+            <a:endParaRPr lang="nn-NO" dirty="0"/>
+          </a:p>
+          <a:p>
             <a:pPr lvl="1">
               <a:buFont typeface="Arial" panose="020B0604020202020204" pitchFamily="34" charset="0"/>
               <a:buChar char="•"/>
@@ -6466,6 +6592,10 @@
               <a:rPr lang="nn-NO" dirty="0"/>
               <a:t>Tingkatkan produktivitas dengan peringatan real-time dan analisis kinerja</a:t>
             </a:r>
+          </a:p>
+          <a:p>
+            <a:pPr lvl="1"/>
+            <a:endParaRPr lang="nn-NO" dirty="0"/>
           </a:p>
           <a:p>
             <a:pPr lvl="1">
@@ -6594,8 +6724,8 @@
         </p:nvSpPr>
         <p:spPr>
           <a:xfrm>
-            <a:off x="6883401" y="2054705"/>
-            <a:ext cx="4775199" cy="2862322"/>
+            <a:off x="6664740" y="887399"/>
+            <a:ext cx="4775199" cy="3970318"/>
           </a:xfrm>
           <a:prstGeom prst="rect">
             <a:avLst/>
@@ -6644,6 +6774,9 @@
               <a:rPr lang="en-ID" b="1" dirty="0" err="1"/>
               <a:t>produksi</a:t>
             </a:r>
+            <a:endParaRPr lang="en-ID" b="1" dirty="0"/>
+          </a:p>
+          <a:p>
             <a:endParaRPr lang="en-ID" dirty="0"/>
           </a:p>
           <a:p>
@@ -6695,6 +6828,8 @@
               <a:rPr lang="en-ID" b="1" dirty="0"/>
               <a:t> Anda?</a:t>
             </a:r>
+          </a:p>
+          <a:p>
             <a:endParaRPr lang="en-ID" dirty="0"/>
           </a:p>
           <a:p>
@@ -6736,6 +6871,10 @@
             </a:r>
           </a:p>
           <a:p>
+            <a:pPr lvl="1"/>
+            <a:endParaRPr lang="en-ID" dirty="0"/>
+          </a:p>
+          <a:p>
             <a:pPr lvl="1">
               <a:buFont typeface="Arial" panose="020B0604020202020204" pitchFamily="34" charset="0"/>
               <a:buChar char="•"/>
@@ -6764,6 +6903,10 @@
               <a:rPr lang="en-ID" dirty="0"/>
               <a:t> material (material flow)</a:t>
             </a:r>
+          </a:p>
+          <a:p>
+            <a:pPr lvl="1"/>
+            <a:endParaRPr lang="en-ID" dirty="0"/>
           </a:p>
           <a:p>
             <a:pPr lvl="1">
@@ -6923,7 +7066,7 @@
         </p:blipFill>
         <p:spPr>
           <a:xfrm>
-            <a:off x="-297170" y="1320800"/>
+            <a:off x="-476074" y="1376089"/>
             <a:ext cx="6689503" cy="4934879"/>
           </a:xfrm>
           <a:prstGeom prst="rect">
@@ -6945,8 +7088,8 @@
         </p:nvSpPr>
         <p:spPr>
           <a:xfrm>
-            <a:off x="6094412" y="1535205"/>
-            <a:ext cx="6249988" cy="2308324"/>
+            <a:off x="5506278" y="916364"/>
+            <a:ext cx="6510130" cy="3139321"/>
           </a:xfrm>
           <a:prstGeom prst="rect">
             <a:avLst/>
@@ -7050,6 +7193,8 @@
               <a:rPr lang="en-ID" b="1" dirty="0"/>
               <a:t> Anda?</a:t>
             </a:r>
+          </a:p>
+          <a:p>
             <a:endParaRPr lang="en-ID" dirty="0"/>
           </a:p>
           <a:p>
@@ -7107,6 +7252,10 @@
             </a:r>
           </a:p>
           <a:p>
+            <a:pPr lvl="1"/>
+            <a:endParaRPr lang="en-ID" dirty="0"/>
+          </a:p>
+          <a:p>
             <a:pPr lvl="1">
               <a:buFont typeface="Arial" panose="020B0604020202020204" pitchFamily="34" charset="0"/>
               <a:buChar char="•"/>
@@ -7187,6 +7336,10 @@
               <a:rPr lang="en-ID" dirty="0" err="1"/>
               <a:t>logis</a:t>
             </a:r>
+            <a:endParaRPr lang="en-ID" dirty="0"/>
+          </a:p>
+          <a:p>
+            <a:pPr lvl="1"/>
             <a:endParaRPr lang="en-ID" dirty="0"/>
           </a:p>
           <a:p>
@@ -7304,7 +7457,7 @@
         </p:nvSpPr>
         <p:spPr>
           <a:xfrm>
-            <a:off x="364066" y="518067"/>
+            <a:off x="0" y="547032"/>
             <a:ext cx="6096000" cy="369332"/>
           </a:xfrm>
           <a:prstGeom prst="rect">
@@ -7318,6 +7471,7 @@
           </a:bodyPr>
           <a:lstStyle/>
           <a:p>
+            <a:pPr algn="ctr"/>
             <a:r>
               <a:rPr lang="en-ID" b="1" i="0" dirty="0">
                 <a:solidFill>
@@ -7557,6 +7711,7 @@
               </a:defRPr>
             </a:pPr>
             <a:r>
+              <a:rPr dirty="0"/>
               <a:t>02</a:t>
             </a:r>
           </a:p>
@@ -7573,8 +7728,26 @@
               </a:defRPr>
             </a:pPr>
             <a:r>
-              <a:t>Eksekusi Lini Produksi</a:t>
-            </a:r>
+              <a:rPr dirty="0" err="1"/>
+              <a:t>Eksekusi</a:t>
+            </a:r>
+            <a:r>
+              <a:rPr dirty="0"/>
+              <a:t> </a:t>
+            </a:r>
+            <a:r>
+              <a:rPr dirty="0" err="1"/>
+              <a:t>Lini</a:t>
+            </a:r>
+            <a:r>
+              <a:rPr dirty="0"/>
+              <a:t> </a:t>
+            </a:r>
+            <a:r>
+              <a:rPr dirty="0" err="1"/>
+              <a:t>Produksi</a:t>
+            </a:r>
+            <a:endParaRPr dirty="0"/>
           </a:p>
           <a:p>
             <a:pPr>
@@ -7589,7 +7762,84 @@
               </a:defRPr>
             </a:pPr>
             <a:r>
-              <a:t>Mengarahkan operator melalui instruksi kerja digital terintegrasi, melacak OEE secara real-time, dan menghentikan stasiun saat Andon downtime.</a:t>
+              <a:rPr dirty="0" err="1"/>
+              <a:t>Mengarahkan</a:t>
+            </a:r>
+            <a:r>
+              <a:rPr dirty="0"/>
+              <a:t> operator </a:t>
+            </a:r>
+            <a:r>
+              <a:rPr dirty="0" err="1"/>
+              <a:t>melalui</a:t>
+            </a:r>
+            <a:r>
+              <a:rPr dirty="0"/>
+              <a:t> </a:t>
+            </a:r>
+            <a:r>
+              <a:rPr dirty="0" err="1"/>
+              <a:t>instruksi</a:t>
+            </a:r>
+            <a:r>
+              <a:rPr dirty="0"/>
+              <a:t> </a:t>
+            </a:r>
+            <a:r>
+              <a:rPr dirty="0" err="1"/>
+              <a:t>kerja</a:t>
+            </a:r>
+            <a:r>
+              <a:rPr dirty="0"/>
+              <a:t> digital </a:t>
+            </a:r>
+            <a:r>
+              <a:rPr dirty="0" err="1"/>
+              <a:t>terintegrasi</a:t>
+            </a:r>
+            <a:r>
+              <a:rPr dirty="0"/>
+              <a:t>, </a:t>
+            </a:r>
+            <a:r>
+              <a:rPr dirty="0" err="1"/>
+              <a:t>melacak</a:t>
+            </a:r>
+            <a:r>
+              <a:rPr dirty="0"/>
+              <a:t> OEE </a:t>
+            </a:r>
+            <a:r>
+              <a:rPr dirty="0" err="1"/>
+              <a:t>secara</a:t>
+            </a:r>
+            <a:r>
+              <a:rPr dirty="0"/>
+              <a:t> real-time, dan </a:t>
+            </a:r>
+            <a:r>
+              <a:rPr dirty="0" err="1"/>
+              <a:t>menghentikan</a:t>
+            </a:r>
+            <a:r>
+              <a:rPr dirty="0"/>
+              <a:t> </a:t>
+            </a:r>
+            <a:r>
+              <a:rPr dirty="0" err="1"/>
+              <a:t>stasiun</a:t>
+            </a:r>
+            <a:r>
+              <a:rPr dirty="0"/>
+              <a:t> </a:t>
+            </a:r>
+            <a:r>
+              <a:rPr dirty="0" err="1"/>
+              <a:t>saat</a:t>
+            </a:r>
+            <a:r>
+              <a:rPr dirty="0"/>
+              <a:t> Andon downtime.</a:t>
             </a:r>
           </a:p>
         </p:txBody>

</xml_diff>